<commit_message>
feat(lecture-03): add 26-slide PPTX deck, figures, and 1920x1080 slide previews
</commit_message>
<xml_diff>
--- a/course_materials/semester_4/lectures/lecture_03_comparative_variations.pptx
+++ b/course_materials/semester_4/lectures/lecture_03_comparative_variations.pptx
@@ -4762,7 +4762,7 @@
         </p:blipFill>
         <p:spPr>
           <a:xfrm>
-            <a:off x="5449824" y="1371600"/>
+            <a:off x="5455767" y="1325880"/>
             <a:ext cx="1280160" cy="1280160"/>
           </a:xfrm>
           <a:prstGeom prst="rect">
@@ -4778,8 +4778,8 @@
         </p:nvSpPr>
         <p:spPr>
           <a:xfrm>
-            <a:off x="1371600" y="2834640"/>
-            <a:ext cx="9448495" cy="320040"/>
+            <a:off x="1371600" y="2761488"/>
+            <a:ext cx="9448495" cy="228600"/>
           </a:xfrm>
           <a:prstGeom prst="rect">
             <a:avLst/>
@@ -4787,7 +4787,7 @@
           <a:noFill/>
         </p:spPr>
         <p:txBody>
-          <a:bodyPr wrap="square">
+          <a:bodyPr wrap="square" lIns="0" rIns="0" tIns="0" bIns="0">
             <a:spAutoFit/>
           </a:bodyPr>
           <a:lstStyle/>
@@ -4814,8 +4814,8 @@
         </p:nvSpPr>
         <p:spPr>
           <a:xfrm>
-            <a:off x="914400" y="3200400"/>
-            <a:ext cx="10362895" cy="685800"/>
+            <a:off x="914400" y="3127248"/>
+            <a:ext cx="10362895" cy="804672"/>
           </a:xfrm>
           <a:prstGeom prst="rect">
             <a:avLst/>
@@ -4823,13 +4823,13 @@
           <a:noFill/>
         </p:spPr>
         <p:txBody>
-          <a:bodyPr wrap="square">
+          <a:bodyPr wrap="square" lIns="0" rIns="0" tIns="0" bIns="0">
             <a:spAutoFit/>
           </a:bodyPr>
           <a:lstStyle/>
           <a:p>
             <a:pPr algn="ctr">
-              <a:defRPr sz="2600" b="1">
+              <a:defRPr sz="2400" b="1">
                 <a:solidFill>
                   <a:srgbClr val="FFFFFF"/>
                 </a:solidFill>
@@ -4850,8 +4850,8 @@
         </p:nvSpPr>
         <p:spPr>
           <a:xfrm>
-            <a:off x="1280160" y="3977639"/>
-            <a:ext cx="9631375" cy="777240"/>
+            <a:off x="1005840" y="4078224"/>
+            <a:ext cx="10180015" cy="822960"/>
           </a:xfrm>
           <a:prstGeom prst="rect">
             <a:avLst/>
@@ -4859,13 +4859,13 @@
           <a:noFill/>
         </p:spPr>
         <p:txBody>
-          <a:bodyPr wrap="square">
+          <a:bodyPr wrap="square" lIns="0" rIns="0" tIns="0" bIns="0">
             <a:spAutoFit/>
           </a:bodyPr>
           <a:lstStyle/>
           <a:p>
             <a:pPr algn="ctr">
-              <a:defRPr sz="1600">
+              <a:defRPr sz="1300">
                 <a:solidFill>
                   <a:srgbClr val="DCEBFA"/>
                 </a:solidFill>
@@ -4886,8 +4886,8 @@
         </p:nvSpPr>
         <p:spPr>
           <a:xfrm>
-            <a:off x="1432407" y="4983480"/>
-            <a:ext cx="2926080" cy="438912"/>
+            <a:off x="1478127" y="5074920"/>
+            <a:ext cx="2926080" cy="457200"/>
           </a:xfrm>
           <a:prstGeom prst="roundRect">
             <a:avLst/>
@@ -4916,7 +4916,7 @@
           </a:fontRef>
         </p:style>
         <p:txBody>
-          <a:bodyPr rtlCol="0" anchor="ctr" wrap="square"/>
+          <a:bodyPr rtlCol="0" anchor="ctr" wrap="square" lIns="54864" rIns="54864" tIns="18288" bIns="18288"/>
           <a:lstStyle/>
           <a:p>
             <a:pPr algn="ctr">
@@ -4941,8 +4941,8 @@
         </p:nvSpPr>
         <p:spPr>
           <a:xfrm>
-            <a:off x="4632807" y="4983480"/>
-            <a:ext cx="2926080" cy="438912"/>
+            <a:off x="4632807" y="5074920"/>
+            <a:ext cx="2926080" cy="457200"/>
           </a:xfrm>
           <a:prstGeom prst="roundRect">
             <a:avLst/>
@@ -4971,7 +4971,7 @@
           </a:fontRef>
         </p:style>
         <p:txBody>
-          <a:bodyPr rtlCol="0" anchor="ctr" wrap="square"/>
+          <a:bodyPr rtlCol="0" anchor="ctr" wrap="square" lIns="54864" rIns="54864" tIns="18288" bIns="18288"/>
           <a:lstStyle/>
           <a:p>
             <a:pPr algn="ctr">
@@ -5020,8 +5020,8 @@
         </p:nvSpPr>
         <p:spPr>
           <a:xfrm>
-            <a:off x="7833207" y="4983480"/>
-            <a:ext cx="2926080" cy="438912"/>
+            <a:off x="7787487" y="5074920"/>
+            <a:ext cx="2926080" cy="457200"/>
           </a:xfrm>
           <a:prstGeom prst="roundRect">
             <a:avLst/>
@@ -5050,7 +5050,7 @@
           </a:fontRef>
         </p:style>
         <p:txBody>
-          <a:bodyPr rtlCol="0" anchor="ctr" wrap="square"/>
+          <a:bodyPr rtlCol="0" anchor="ctr" wrap="square" lIns="54864" rIns="54864" tIns="18288" bIns="18288"/>
           <a:lstStyle/>
           <a:p>
             <a:pPr algn="ctr">
@@ -9295,7 +9295,7 @@
         </p:blipFill>
         <p:spPr>
           <a:xfrm>
-            <a:off x="5449824" y="1371600"/>
+            <a:off x="5455767" y="1325880"/>
             <a:ext cx="1280160" cy="1280160"/>
           </a:xfrm>
           <a:prstGeom prst="rect">
@@ -9311,8 +9311,8 @@
         </p:nvSpPr>
         <p:spPr>
           <a:xfrm>
-            <a:off x="1371600" y="2834640"/>
-            <a:ext cx="9448495" cy="320040"/>
+            <a:off x="1371600" y="2761488"/>
+            <a:ext cx="9448495" cy="228600"/>
           </a:xfrm>
           <a:prstGeom prst="rect">
             <a:avLst/>
@@ -9320,7 +9320,7 @@
           <a:noFill/>
         </p:spPr>
         <p:txBody>
-          <a:bodyPr wrap="square">
+          <a:bodyPr wrap="square" lIns="0" rIns="0" tIns="0" bIns="0">
             <a:spAutoFit/>
           </a:bodyPr>
           <a:lstStyle/>
@@ -9347,8 +9347,8 @@
         </p:nvSpPr>
         <p:spPr>
           <a:xfrm>
-            <a:off x="914400" y="3200400"/>
-            <a:ext cx="10362895" cy="685800"/>
+            <a:off x="914400" y="3127248"/>
+            <a:ext cx="10362895" cy="804672"/>
           </a:xfrm>
           <a:prstGeom prst="rect">
             <a:avLst/>
@@ -9356,13 +9356,13 @@
           <a:noFill/>
         </p:spPr>
         <p:txBody>
-          <a:bodyPr wrap="square">
+          <a:bodyPr wrap="square" lIns="0" rIns="0" tIns="0" bIns="0">
             <a:spAutoFit/>
           </a:bodyPr>
           <a:lstStyle/>
           <a:p>
             <a:pPr algn="ctr">
-              <a:defRPr sz="2600" b="1">
+              <a:defRPr sz="2400" b="1">
                 <a:solidFill>
                   <a:srgbClr val="002C5F"/>
                 </a:solidFill>
@@ -9383,8 +9383,8 @@
         </p:nvSpPr>
         <p:spPr>
           <a:xfrm>
-            <a:off x="1280160" y="3977639"/>
-            <a:ext cx="9631375" cy="777240"/>
+            <a:off x="1005840" y="4078224"/>
+            <a:ext cx="10180015" cy="822960"/>
           </a:xfrm>
           <a:prstGeom prst="rect">
             <a:avLst/>
@@ -9392,13 +9392,13 @@
           <a:noFill/>
         </p:spPr>
         <p:txBody>
-          <a:bodyPr wrap="square">
+          <a:bodyPr wrap="square" lIns="0" rIns="0" tIns="0" bIns="0">
             <a:spAutoFit/>
           </a:bodyPr>
           <a:lstStyle/>
           <a:p>
             <a:pPr algn="ctr">
-              <a:defRPr sz="1600">
+              <a:defRPr sz="1300">
                 <a:solidFill>
                   <a:srgbClr val="242834"/>
                 </a:solidFill>
@@ -9419,8 +9419,8 @@
         </p:nvSpPr>
         <p:spPr>
           <a:xfrm>
-            <a:off x="1432407" y="4983480"/>
-            <a:ext cx="2926080" cy="438912"/>
+            <a:off x="1478127" y="5074920"/>
+            <a:ext cx="2926080" cy="457200"/>
           </a:xfrm>
           <a:prstGeom prst="roundRect">
             <a:avLst/>
@@ -9449,7 +9449,7 @@
           </a:fontRef>
         </p:style>
         <p:txBody>
-          <a:bodyPr rtlCol="0" anchor="ctr" wrap="square"/>
+          <a:bodyPr rtlCol="0" anchor="ctr" wrap="square" lIns="54864" rIns="54864" tIns="18288" bIns="18288"/>
           <a:lstStyle/>
           <a:p>
             <a:pPr algn="ctr">
@@ -9474,8 +9474,8 @@
         </p:nvSpPr>
         <p:spPr>
           <a:xfrm>
-            <a:off x="4632807" y="4983480"/>
-            <a:ext cx="2926080" cy="438912"/>
+            <a:off x="4632807" y="5074920"/>
+            <a:ext cx="2926080" cy="457200"/>
           </a:xfrm>
           <a:prstGeom prst="roundRect">
             <a:avLst/>
@@ -9504,7 +9504,7 @@
           </a:fontRef>
         </p:style>
         <p:txBody>
-          <a:bodyPr rtlCol="0" anchor="ctr" wrap="square"/>
+          <a:bodyPr rtlCol="0" anchor="ctr" wrap="square" lIns="54864" rIns="54864" tIns="18288" bIns="18288"/>
           <a:lstStyle/>
           <a:p>
             <a:pPr algn="ctr">
@@ -9527,7 +9527,7 @@
             <a:r>
               <a:rPr sz="1150" b="1">
                 <a:solidFill>
-                  <a:srgbClr val="002C5F"/>
+                  <a:srgbClr val="005AAA"/>
                 </a:solidFill>
                 <a:latin typeface="Arial"/>
               </a:rPr>
@@ -9553,8 +9553,8 @@
         </p:nvSpPr>
         <p:spPr>
           <a:xfrm>
-            <a:off x="7833207" y="4983480"/>
-            <a:ext cx="2926080" cy="438912"/>
+            <a:off x="7787487" y="5074920"/>
+            <a:ext cx="2926080" cy="457200"/>
           </a:xfrm>
           <a:prstGeom prst="roundRect">
             <a:avLst/>
@@ -9583,7 +9583,7 @@
           </a:fontRef>
         </p:style>
         <p:txBody>
-          <a:bodyPr rtlCol="0" anchor="ctr" wrap="square"/>
+          <a:bodyPr rtlCol="0" anchor="ctr" wrap="square" lIns="54864" rIns="54864" tIns="18288" bIns="18288"/>
           <a:lstStyle/>
           <a:p>
             <a:pPr algn="ctr">
@@ -9606,7 +9606,7 @@
             <a:r>
               <a:rPr sz="1150" b="1">
                 <a:solidFill>
-                  <a:srgbClr val="002C5F"/>
+                  <a:srgbClr val="005AAA"/>
                 </a:solidFill>
                 <a:latin typeface="Arial"/>
               </a:rPr>
@@ -11826,7 +11826,7 @@
             <a:r>
               <a:rPr sz="1100" b="1">
                 <a:solidFill>
-                  <a:srgbClr val="002C5F"/>
+                  <a:srgbClr val="005AAA"/>
                 </a:solidFill>
                 <a:latin typeface="Arial"/>
               </a:rPr>
@@ -11905,7 +11905,7 @@
             <a:r>
               <a:rPr sz="1100" b="1">
                 <a:solidFill>
-                  <a:srgbClr val="002C5F"/>
+                  <a:srgbClr val="005AAA"/>
                 </a:solidFill>
                 <a:latin typeface="Arial"/>
               </a:rPr>
@@ -12165,7 +12165,7 @@
             <a:r>
               <a:rPr sz="1600" b="1">
                 <a:solidFill>
-                  <a:srgbClr val="00BEF3"/>
+                  <a:srgbClr val="005AAA"/>
                 </a:solidFill>
                 <a:latin typeface="Arial"/>
               </a:rPr>

</xml_diff>